<commit_message>
chore(release): v1.4.0 终版发布 — 版本号三处定版(package.json×2+config.py APP_VERSION), 重打 sidecar+NSIS 安装包 KMatch·知链-1.4.0-x64.exe(134.5MB); 新增软件说明/系统部署说明 v1.4.0, README·docs README·比赛资料包(md/docx/PPT)版本对齐; 项目正式收尾(devlog 收官), 代码基线与 v1.3.4 一致
</commit_message>
<xml_diff>
--- a/docs/比赛提交/项目介绍.pptx
+++ b/docs/比赛提交/项目介绍.pptx
@@ -602,7 +602,7 @@
           <a:p>
             <a:r>
               <a:rPr lang="en-US" dirty="0"/>
-              <a:t>发行物 KMatch·知链-1.3.4-x64.exe；端用户零命令行、零配置文件。</a:t>
+              <a:t>发行物 KMatch·知链-1.4.0-x64.exe；端用户零命令行、零配置文件。</a:t>
             </a:r>
             <a:endParaRPr lang="en-US" dirty="0"/>
           </a:p>
@@ -2646,7 +2646,7 @@
                 <a:ea typeface="Microsoft YaHei" pitchFamily="34" charset="-122"/>
                 <a:cs typeface="Microsoft YaHei" pitchFamily="34" charset="-120"/>
               </a:rPr>
-              <a:t>v1.3.4 · Windows 桌面应用 · 2026-09</a:t>
+              <a:t>v1.4.0 · Windows 桌面应用 · 2026-09（终版）</a:t>
             </a:r>
             <a:endParaRPr lang="en-US" sz="1250" dirty="0"/>
           </a:p>
@@ -3957,7 +3957,7 @@
                 <a:ea typeface="Microsoft YaHei" pitchFamily="34" charset="-122"/>
                 <a:cs typeface="Microsoft YaHei" pitchFamily="34" charset="-120"/>
               </a:rPr>
-              <a:t>2026-09-03 · v1.3.4 实测</a:t>
+              <a:t>2026-09-03 · v1.4.0 实测（基线同 v1.3.4）</a:t>
             </a:r>
             <a:endParaRPr lang="en-US" sz="1700" dirty="0"/>
           </a:p>
@@ -6867,7 +6867,7 @@
                 <a:ea typeface="Microsoft YaHei" pitchFamily="34" charset="-122"/>
                 <a:cs typeface="Microsoft YaHei" pitchFamily="34" charset="-120"/>
               </a:rPr>
-              <a:t>KMatch·知链-1.3.4-x64.exe（Windows · 免 Docker）</a:t>
+              <a:t>KMatch·知链-1.4.0-x64.exe（Windows · 免 Docker · 终版）</a:t>
             </a:r>
             <a:endParaRPr lang="en-US" sz="1150" dirty="0"/>
           </a:p>

</xml_diff>